<commit_message>
update offer pptx template
</commit_message>
<xml_diff>
--- a/docs/archive/fable/szablon_testowy.pptx
+++ b/docs/archive/fable/szablon_testowy.pptx
@@ -7,6 +7,7 @@
   <p:sldIdLst>
     <p:sldId id="256" r:id="rId7"/>
     <p:sldId id="257" r:id="rId8"/>
+    <p:sldId id="260" r:id="rId12"/>
     <p:sldId id="258" r:id="rId10"/>
     <p:sldId id="259" r:id="rId11"/>
   </p:sldIdLst>
@@ -645,7 +646,77 @@
           <a:lstStyle/>
           <a:p>
             <a:r>
-              <a:t>repeat:goal</a:t>
+              <a:t>repeat:nonexistent</a:t>
+            </a:r>
+          </a:p>
+        </p:txBody>
+      </p:sp>
+      <p:sp>
+        <p:nvSpPr>
+          <p:cNvPr id="4" name="Slide Number Placeholder 3"/>
+          <p:cNvSpPr>
+            <a:spLocks noGrp="1"/>
+          </p:cNvSpPr>
+          <p:nvPr>
+            <p:ph type="sldNum" idx="5" sz="quarter"/>
+          </p:nvPr>
+        </p:nvSpPr>
+        <p:spPr/>
+      </p:sp>
+    </p:spTree>
+  </p:cSld>
+  <p:clrMapOvr>
+    <a:masterClrMapping/>
+  </p:clrMapOvr>
+</p:notes>
+</file>
+
+<file path=ppt/notesSlides/notesSlide4.xml><?xml version="1.0" encoding="utf-8"?>
+<p:notes xmlns:a="http://schemas.openxmlformats.org/drawingml/2006/main" xmlns:p="http://schemas.openxmlformats.org/presentationml/2006/main" xmlns:r="http://schemas.openxmlformats.org/officeDocument/2006/relationships">
+  <p:cSld>
+    <p:spTree>
+      <p:nvGrpSpPr>
+        <p:cNvPr id="1" name=""/>
+        <p:cNvGrpSpPr/>
+        <p:nvPr/>
+      </p:nvGrpSpPr>
+      <p:grpSpPr>
+        <a:xfrm>
+          <a:off x="0" y="0"/>
+          <a:ext cx="0" cy="0"/>
+          <a:chOff x="0" y="0"/>
+          <a:chExt cx="0" cy="0"/>
+        </a:xfrm>
+      </p:grpSpPr>
+      <p:sp>
+        <p:nvSpPr>
+          <p:cNvPr id="2" name="Slide Image Placeholder 1"/>
+          <p:cNvSpPr>
+            <a:spLocks noGrp="1"/>
+          </p:cNvSpPr>
+          <p:nvPr>
+            <p:ph type="sldImg" idx="2"/>
+          </p:nvPr>
+        </p:nvSpPr>
+        <p:spPr/>
+      </p:sp>
+      <p:sp>
+        <p:nvSpPr>
+          <p:cNvPr id="3" name="Notes Placeholder 2"/>
+          <p:cNvSpPr>
+            <a:spLocks noGrp="1"/>
+          </p:cNvSpPr>
+          <p:nvPr>
+            <p:ph type="body" idx="3" sz="quarter"/>
+          </p:nvPr>
+        </p:nvSpPr>
+        <p:spPr/>
+        <p:txBody>
+          <a:bodyPr/>
+          <a:lstStyle/>
+          <a:p>
+            <a:r>
+              <a:t>repeat:module</a:t>
             </a:r>
           </a:p>
         </p:txBody>
@@ -3710,25 +3781,61 @@
           <a:p>
             <a:r>
               <a:rPr sz="1300"/>
-              <a:t>lead.name: {{lead.name}}   |   lead.type: {{lead.type}}   |   lead.stage: {{lead.stage}}</a:t>
+              <a:t>lead.type: {{lead.type}}   |   lead.contact_email: {{lead.contact_email}}</a:t>
             </a:r>
           </a:p>
           <a:p>
             <a:r>
               <a:rPr sz="1300"/>
-              <a:t>lead.value: {{lead.value}}   |   lead.training_hours: {{lead.training_hours}}</a:t>
+              <a:t>lead.contact_phone: {{lead.contact_phone}}   |   lead.industry: {{lead.industry}}</a:t>
             </a:r>
           </a:p>
           <a:p>
             <a:r>
               <a:rPr sz="1300"/>
-              <a:t>lead.training_goals: {{lead.training_goals}}</a:t>
+              <a:t>lead.notes: {{lead.notes}}</a:t>
             </a:r>
           </a:p>
           <a:p>
             <a:r>
               <a:rPr sz="1300"/>
-              <a:t>company.name: {{company.name}}</a:t>
+              <a:t>company.name: {{company.name}}   |   company.industry: {{company.industry}}</a:t>
+            </a:r>
+          </a:p>
+          <a:p>
+            <a:r>
+              <a:rPr sz="1300"/>
+              <a:t>company.notes: {{company.notes}}</a:t>
+            </a:r>
+          </a:p>
+          <a:p>
+            <a:r>
+              <a:rPr sz="1300"/>
+              <a:t>company.communication_processes: {{company.communication_processes}}</a:t>
+            </a:r>
+          </a:p>
+          <a:p>
+            <a:r>
+              <a:rPr sz="1300"/>
+              <a:t>company.business_impact: {{company.business_impact}}</a:t>
+            </a:r>
+          </a:p>
+          <a:p>
+            <a:r>
+              <a:rPr sz="1300"/>
+              <a:t>meeting.goals: {{meeting.goals}}   |   meeting.challenges: {{meeting.challenges}}</a:t>
+            </a:r>
+          </a:p>
+          <a:p>
+            <a:r>
+              <a:rPr sz="1300"/>
+              <a:t>meeting.business_context: {{meeting.business_context}}</a:t>
+            </a:r>
+          </a:p>
+          <a:p>
+            <a:r>
+              <a:rPr sz="1300"/>
+              <a:t>meeting.communication_situations: {{meeting.communication_situations}}</a:t>
             </a:r>
           </a:p>
           <a:p>
@@ -3828,7 +3935,19 @@
           <a:p>
             <a:r>
               <a:rPr sz="1300"/>
-              <a:t>needs_summary: {{participant.needs_summary}}</a:t>
+              <a:t/>
+            </a:r>
+          </a:p>
+          <a:p>
+            <a:r>
+              <a:rPr sz="1300"/>
+              <a:t>OCENY - skrot a.*:   o={{a.o}}  r={{a.r}}  a={{a.a}}  f={{a.f}}  c={{a.c}}</a:t>
+            </a:r>
+          </a:p>
+          <a:p>
+            <a:r>
+              <a:rPr sz="1300"/>
+              <a:t>OCENY - z prefiksem: o={{participant.a.o}}  r={{participant.a.r}}</a:t>
             </a:r>
           </a:p>
           <a:p>
@@ -3840,13 +3959,19 @@
           <a:p>
             <a:r>
               <a:rPr sz="1300"/>
-              <a:t>OCENY - skrot a.*:   o={{a.o}}  r={{a.r}}  a={{a.a}}  f={{a.f}}  c={{a.c}}</a:t>
+              <a:t>assessment.needs_summary: {{assessment.needs_summary}}</a:t>
             </a:r>
           </a:p>
           <a:p>
             <a:r>
               <a:rPr sz="1300"/>
-              <a:t>OCENY - z prefiksem: o={{participant.a.o}}  r={{participant.a.r}}</a:t>
+              <a:t>assessment.strengths: {{assessment.strengths}}</a:t>
+            </a:r>
+          </a:p>
+          <a:p>
+            <a:r>
+              <a:rPr sz="1300"/>
+              <a:t>assessment.gaps: {{assessment.gaps}}</a:t>
             </a:r>
           </a:p>
           <a:p>
@@ -3858,19 +3983,19 @@
           <a:p>
             <a:r>
               <a:rPr sz="1300"/>
-              <a:t>assessment.position: {{assessment.position}}</a:t>
+              <a:t>recommendation.type: {{recommendation.type}}   |   recommendation.priority: {{recommendation.priority}}</a:t>
             </a:r>
           </a:p>
           <a:p>
             <a:r>
               <a:rPr sz="1300"/>
-              <a:t>assessment.needs_summary: {{assessment.needs_summary}}</a:t>
+              <a:t>recommendation.headline: {{recommendation.headline}}</a:t>
             </a:r>
           </a:p>
           <a:p>
             <a:r>
               <a:rPr sz="1300"/>
-              <a:t>assessment.title: {{assessment.title}}   |   assessment.level: {{assessment.level}}</a:t>
+              <a:t>recommendation.rationale: {{recommendation.rationale}}</a:t>
             </a:r>
           </a:p>
         </p:txBody>
@@ -3917,7 +4042,7 @@
           <a:p>
             <a:r>
               <a:rPr sz="2400" b="1"/>
-              <a:t>3. REFERENCJA — notatka: repeat:testimonial</a:t>
+              <a:t>4. REFERENCJA — notatka: repeat:testimonial</a:t>
             </a:r>
           </a:p>
         </p:txBody>
@@ -4023,7 +4148,7 @@
           <a:p>
             <a:r>
               <a:rPr sz="2400" b="1"/>
-              <a:t>4. PUSTA LISTA — notatka: repeat:goal</a:t>
+              <a:t>5. PUSTA LISTA — notatka: repeat:nonexistent</a:t>
             </a:r>
           </a:p>
         </p:txBody>
@@ -4052,19 +4177,137 @@
           <a:p>
             <a:r>
               <a:rPr sz="1300"/>
-              <a:t>Ten slajd MA zniknac z wyniku (brak klucza 'goal' w danych)</a:t>
+              <a:t>Ten slajd MA zniknac z wyniku (brak klucza 'nonexistent' w danych)</a:t>
             </a:r>
           </a:p>
           <a:p>
             <a:r>
               <a:rPr sz="1300"/>
-              <a:t>i zostawic ostrzezenie: repeat:goal slide dropped - no items</a:t>
+              <a:t>i zostawic ostrzezenie: repeat:nonexistent slide dropped - no items</a:t>
             </a:r>
           </a:p>
           <a:p>
             <a:r>
               <a:rPr sz="1300"/>
-              <a:t>{{goal.title}}</a:t>
+              <a:t>{{nonexistent.title}}</a:t>
+            </a:r>
+          </a:p>
+        </p:txBody>
+      </p:sp>
+    </p:spTree>
+  </p:cSld>
+  <p:clrMapOvr>
+    <a:masterClrMapping/>
+  </p:clrMapOvr>
+</p:sld>
+</file>
+
+<file path=ppt/slides/slide5.xml><?xml version="1.0" encoding="utf-8"?>
+<p:sld xmlns:a="http://schemas.openxmlformats.org/drawingml/2006/main" xmlns:p="http://schemas.openxmlformats.org/presentationml/2006/main" xmlns:r="http://schemas.openxmlformats.org/officeDocument/2006/relationships">
+  <p:cSld>
+    <p:spTree>
+      <p:nvGrpSpPr>
+        <p:cNvPr id="1" name=""/>
+        <p:cNvGrpSpPr/>
+        <p:nvPr/>
+      </p:nvGrpSpPr>
+      <p:grpSpPr/>
+      <p:sp>
+        <p:nvSpPr>
+          <p:cNvPr id="2" name="TextBox 1"/>
+          <p:cNvSpPr txBox="1"/>
+          <p:nvPr/>
+        </p:nvSpPr>
+        <p:spPr>
+          <a:xfrm>
+            <a:off x="365760" y="274320"/>
+            <a:ext cx="11430000" cy="548640"/>
+          </a:xfrm>
+          <a:prstGeom prst="rect">
+            <a:avLst/>
+          </a:prstGeom>
+          <a:noFill/>
+        </p:spPr>
+        <p:txBody>
+          <a:bodyPr wrap="none">
+            <a:spAutoFit/>
+          </a:bodyPr>
+          <a:lstStyle/>
+          <a:p>
+            <a:r>
+              <a:rPr sz="2400" b="1"/>
+              <a:t>3. MODUL — notatka: repeat:module</a:t>
+            </a:r>
+          </a:p>
+        </p:txBody>
+      </p:sp>
+      <p:sp>
+        <p:nvSpPr>
+          <p:cNvPr id="3" name="TextBox 2"/>
+          <p:cNvSpPr txBox="1"/>
+          <p:nvPr/>
+        </p:nvSpPr>
+        <p:spPr>
+          <a:xfrm>
+            <a:off x="365760" y="1005840"/>
+            <a:ext cx="11430000" cy="5486400"/>
+          </a:xfrm>
+          <a:prstGeom prst="rect">
+            <a:avLst/>
+          </a:prstGeom>
+          <a:noFill/>
+        </p:spPr>
+        <p:txBody>
+          <a:bodyPr wrap="square">
+            <a:spAutoFit/>
+          </a:bodyPr>
+          <a:lstStyle/>
+          <a:p>
+            <a:r>
+              <a:rPr sz="1300"/>
+              <a:t>sort_order: {{module.sort_order}}   |   hours: {{module.hours}}   |   mode: {{module.mode}}</a:t>
+            </a:r>
+          </a:p>
+          <a:p>
+            <a:r>
+              <a:rPr sz="1300"/>
+              <a:t>title: {{module.title}}</a:t>
+            </a:r>
+          </a:p>
+          <a:p>
+            <a:r>
+              <a:rPr sz="1300"/>
+              <a:t>goal_statement: {{module.goal_statement}}</a:t>
+            </a:r>
+          </a:p>
+          <a:p>
+            <a:r>
+              <a:rPr sz="1300"/>
+              <a:t>participant_name: {{module.participant_name}}</a:t>
+            </a:r>
+          </a:p>
+          <a:p>
+            <a:r>
+              <a:rPr sz="1300"/>
+              <a:t/>
+            </a:r>
+          </a:p>
+          <a:p>
+            <a:r>
+              <a:rPr sz="1300"/>
+              <a:t>ETAP {{module.sort_order}}: {{module.title}} ({{module.hours}}h, {{module.mode}}) dla {{module.participant_name}}</a:t>
+            </a:r>
+          </a:p>
+          <a:p>
+            <a:r>
+              <a:rPr sz="1300"/>
+              <a:t/>
+            </a:r>
+          </a:p>
+          <a:p>
+            <a:r>
+              <a:rPr sz="1300"/>
+              <a:t>PULAPKA: na tym slajdzie participant.full_name celuje w globalna liste, nie w osobe - dlatego jest module.participant_name</a:t>
             </a:r>
           </a:p>
         </p:txBody>

</xml_diff>